<commit_message>
Last changes while at the event.
</commit_message>
<xml_diff>
--- a/slides/agrisense_bw.pptx
+++ b/slides/agrisense_bw.pptx
@@ -997,7 +997,7 @@
           <a:p>
             <a:fld id="{5BCAD085-E8A6-8845-BD4E-CB4CCA059FC4}" type="datetimeFigureOut">
               <a:rPr lang="en-US" smtClean="0"/>
-              <a:t>10/14/26</a:t>
+              <a:t>10/16/26</a:t>
             </a:fld>
             <a:endParaRPr lang="en-US"/>
           </a:p>
@@ -1165,7 +1165,7 @@
           <a:p>
             <a:fld id="{5BCAD085-E8A6-8845-BD4E-CB4CCA059FC4}" type="datetimeFigureOut">
               <a:rPr lang="en-US" smtClean="0"/>
-              <a:t>10/14/26</a:t>
+              <a:t>10/16/26</a:t>
             </a:fld>
             <a:endParaRPr lang="en-US"/>
           </a:p>
@@ -1343,7 +1343,7 @@
           <a:p>
             <a:fld id="{5BCAD085-E8A6-8845-BD4E-CB4CCA059FC4}" type="datetimeFigureOut">
               <a:rPr lang="en-US" smtClean="0"/>
-              <a:t>10/14/26</a:t>
+              <a:t>10/16/26</a:t>
             </a:fld>
             <a:endParaRPr lang="en-US"/>
           </a:p>
@@ -1511,7 +1511,7 @@
           <a:p>
             <a:fld id="{5BCAD085-E8A6-8845-BD4E-CB4CCA059FC4}" type="datetimeFigureOut">
               <a:rPr lang="en-US" smtClean="0"/>
-              <a:t>10/14/26</a:t>
+              <a:t>10/16/26</a:t>
             </a:fld>
             <a:endParaRPr lang="en-US"/>
           </a:p>
@@ -1756,7 +1756,7 @@
           <a:p>
             <a:fld id="{5BCAD085-E8A6-8845-BD4E-CB4CCA059FC4}" type="datetimeFigureOut">
               <a:rPr lang="en-US" smtClean="0"/>
-              <a:t>10/14/26</a:t>
+              <a:t>10/16/26</a:t>
             </a:fld>
             <a:endParaRPr lang="en-US"/>
           </a:p>
@@ -2041,7 +2041,7 @@
           <a:p>
             <a:fld id="{5BCAD085-E8A6-8845-BD4E-CB4CCA059FC4}" type="datetimeFigureOut">
               <a:rPr lang="en-US" smtClean="0"/>
-              <a:t>10/14/26</a:t>
+              <a:t>10/16/26</a:t>
             </a:fld>
             <a:endParaRPr lang="en-US"/>
           </a:p>
@@ -2460,7 +2460,7 @@
           <a:p>
             <a:fld id="{5BCAD085-E8A6-8845-BD4E-CB4CCA059FC4}" type="datetimeFigureOut">
               <a:rPr lang="en-US" smtClean="0"/>
-              <a:t>10/14/26</a:t>
+              <a:t>10/16/26</a:t>
             </a:fld>
             <a:endParaRPr lang="en-US"/>
           </a:p>
@@ -2577,7 +2577,7 @@
           <a:p>
             <a:fld id="{5BCAD085-E8A6-8845-BD4E-CB4CCA059FC4}" type="datetimeFigureOut">
               <a:rPr lang="en-US" smtClean="0"/>
-              <a:t>10/14/26</a:t>
+              <a:t>10/16/26</a:t>
             </a:fld>
             <a:endParaRPr lang="en-US"/>
           </a:p>
@@ -2672,7 +2672,7 @@
           <a:p>
             <a:fld id="{5BCAD085-E8A6-8845-BD4E-CB4CCA059FC4}" type="datetimeFigureOut">
               <a:rPr lang="en-US" smtClean="0"/>
-              <a:t>10/14/26</a:t>
+              <a:t>10/16/26</a:t>
             </a:fld>
             <a:endParaRPr lang="en-US"/>
           </a:p>
@@ -2947,7 +2947,7 @@
           <a:p>
             <a:fld id="{5BCAD085-E8A6-8845-BD4E-CB4CCA059FC4}" type="datetimeFigureOut">
               <a:rPr lang="en-US" smtClean="0"/>
-              <a:t>10/14/26</a:t>
+              <a:t>10/16/26</a:t>
             </a:fld>
             <a:endParaRPr lang="en-US"/>
           </a:p>
@@ -3199,7 +3199,7 @@
           <a:p>
             <a:fld id="{5BCAD085-E8A6-8845-BD4E-CB4CCA059FC4}" type="datetimeFigureOut">
               <a:rPr lang="en-US" smtClean="0"/>
-              <a:t>10/14/26</a:t>
+              <a:t>10/16/26</a:t>
             </a:fld>
             <a:endParaRPr lang="en-US"/>
           </a:p>
@@ -3410,7 +3410,7 @@
           <a:p>
             <a:fld id="{5BCAD085-E8A6-8845-BD4E-CB4CCA059FC4}" type="datetimeFigureOut">
               <a:rPr lang="en-US" smtClean="0"/>
-              <a:t>10/14/26</a:t>
+              <a:t>10/16/26</a:t>
             </a:fld>
             <a:endParaRPr lang="en-US"/>
           </a:p>
@@ -7230,7 +7230,7 @@
               </a:spcAft>
             </a:pPr>
             <a:r>
-              <a:rPr sz="1800" b="1">
+              <a:rPr sz="1800" b="1" dirty="0">
                 <a:solidFill>
                   <a:srgbClr val="1D2B36"/>
                 </a:solidFill>
@@ -7246,13 +7246,22 @@
               </a:spcAft>
             </a:pPr>
             <a:r>
-              <a:rPr sz="1600" b="0">
+              <a:rPr lang="en-US" sz="1600" b="0" dirty="0">
                 <a:solidFill>
                   <a:srgbClr val="56626C"/>
                 </a:solidFill>
                 <a:latin typeface="Calibri"/>
               </a:rPr>
-              <a:t>Seeed XIAO nRF52840, GY‑906 infrared thermometer and accelerometer</a:t>
+              <a:t>Arduino UNO</a:t>
+            </a:r>
+            <a:r>
+              <a:rPr sz="1600" b="0" dirty="0">
+                <a:solidFill>
+                  <a:srgbClr val="56626C"/>
+                </a:solidFill>
+                <a:latin typeface="Calibri"/>
+              </a:rPr>
+              <a:t>, GY‑906 infrared thermometer and accelerometer</a:t>
             </a:r>
           </a:p>
         </p:txBody>
@@ -7496,7 +7505,7 @@
         <p:spPr>
           <a:xfrm>
             <a:off x="4818888" y="2834640"/>
-            <a:ext cx="2606040" cy="1371600"/>
+            <a:ext cx="2606040" cy="820738"/>
           </a:xfrm>
           <a:prstGeom prst="rect">
             <a:avLst/>
@@ -7515,7 +7524,7 @@
               </a:spcAft>
             </a:pPr>
             <a:r>
-              <a:rPr sz="1800" b="1">
+              <a:rPr sz="1800" b="1" dirty="0">
                 <a:solidFill>
                   <a:srgbClr val="1D2B36"/>
                 </a:solidFill>
@@ -7531,13 +7540,22 @@
               </a:spcAft>
             </a:pPr>
             <a:r>
-              <a:rPr sz="1600" b="0">
+              <a:rPr lang="en-US" sz="1600" b="0" dirty="0">
                 <a:solidFill>
                   <a:srgbClr val="56626C"/>
                 </a:solidFill>
                 <a:latin typeface="Calibri"/>
               </a:rPr>
-              <a:t>ESP32 and Flying Fish rain sensor, at the kraal or field</a:t>
+              <a:t>Arduino UNO</a:t>
+            </a:r>
+            <a:r>
+              <a:rPr sz="1600" b="0" dirty="0">
+                <a:solidFill>
+                  <a:srgbClr val="56626C"/>
+                </a:solidFill>
+                <a:latin typeface="Calibri"/>
+              </a:rPr>
+              <a:t> and Flying Fish rain sensor, at the kraal or field</a:t>
             </a:r>
           </a:p>
         </p:txBody>

</xml_diff>